<commit_message>
feat(ui): analitica + cinta de filtros en detalle de senal + payload TP + fix multi-leg deliveries
</commit_message>
<xml_diff>
--- a/CONTRATO/NTEXECG_Ejecutivo.pptx
+++ b/CONTRATO/NTEXECG_Ejecutivo.pptx
@@ -16,6 +16,7 @@
     <p:sldId id="264" r:id="rId15"/>
     <p:sldId id="265" r:id="rId16"/>
     <p:sldId id="266" r:id="rId17"/>
+    <p:sldId id="267" r:id="rId18"/>
   </p:sldIdLst>
   <p:sldSz cx="12191695" cy="6858000" type="screen4x3"/>
   <p:notesSz cx="6858000" cy="9144000"/>
@@ -3337,7 +3338,7 @@
                 </a:solidFill>
                 <a:latin typeface="Cambria"/>
               </a:rPr>
-              <a:t>Riesgos y salvaguardas</a:t>
+              <a:t>Estado: validado y operando en demo</a:t>
             </a:r>
           </a:p>
         </p:txBody>
@@ -3350,8 +3351,8 @@
         </p:nvSpPr>
         <p:spPr>
           <a:xfrm>
-            <a:off x="640080" y="1737360"/>
-            <a:ext cx="5394960" cy="4114800"/>
+            <a:off x="640080" y="1828800"/>
+            <a:ext cx="3520440" cy="2011680"/>
           </a:xfrm>
           <a:prstGeom prst="roundRect">
             <a:avLst/>
@@ -3394,8 +3395,8 @@
         </p:nvSpPr>
         <p:spPr>
           <a:xfrm>
-            <a:off x="914400" y="1965960"/>
-            <a:ext cx="4937760" cy="548640"/>
+            <a:off x="640080" y="2057400"/>
+            <a:ext cx="3520440" cy="1005840"/>
           </a:xfrm>
           <a:prstGeom prst="rect">
             <a:avLst/>
@@ -3408,7 +3409,7 @@
           </a:bodyPr>
           <a:lstStyle/>
           <a:p>
-            <a:pPr algn="l">
+            <a:pPr algn="ctr">
               <a:spcBef>
                 <a:spcPts val="0"/>
               </a:spcBef>
@@ -3417,13 +3418,13 @@
               </a:spcAft>
             </a:pPr>
             <a:r>
-              <a:rPr sz="1800" b="1" i="0">
-                <a:solidFill>
-                  <a:srgbClr val="F96167"/>
-                </a:solidFill>
-                <a:latin typeface="Calibri"/>
-              </a:rPr>
-              <a:t>Riesgos</a:t>
+              <a:rPr sz="4600" b="1" i="0">
+                <a:solidFill>
+                  <a:srgbClr val="1E2761"/>
+                </a:solidFill>
+                <a:latin typeface="Cambria"/>
+              </a:rPr>
+              <a:t>8</a:t>
             </a:r>
           </a:p>
         </p:txBody>
@@ -3436,8 +3437,8 @@
         </p:nvSpPr>
         <p:spPr>
           <a:xfrm>
-            <a:off x="914400" y="2697480"/>
-            <a:ext cx="4937760" cy="3108960"/>
+            <a:off x="822959" y="3154680"/>
+            <a:ext cx="3154680" cy="640080"/>
           </a:xfrm>
           <a:prstGeom prst="rect">
             <a:avLst/>
@@ -3450,64 +3451,7 @@
           </a:bodyPr>
           <a:lstStyle/>
           <a:p>
-            <a:pPr algn="l">
-              <a:spcBef>
-                <a:spcPts val="0"/>
-              </a:spcBef>
-              <a:spcAft>
-                <a:spcPts val="1000"/>
-              </a:spcAft>
-            </a:pPr>
-            <a:r>
-              <a:rPr sz="1500" b="0" i="0">
-                <a:solidFill>
-                  <a:srgbClr val="222222"/>
-                </a:solidFill>
-                <a:latin typeface="Calibri"/>
-              </a:rPr>
-              <a:t>Backtest sin comisiones ni slippage.</a:t>
-            </a:r>
-          </a:p>
-          <a:p>
-            <a:pPr algn="l">
-              <a:spcBef>
-                <a:spcPts val="0"/>
-              </a:spcBef>
-              <a:spcAft>
-                <a:spcPts val="1000"/>
-              </a:spcAft>
-            </a:pPr>
-            <a:r>
-              <a:rPr sz="1500" b="0" i="0">
-                <a:solidFill>
-                  <a:srgbClr val="222222"/>
-                </a:solidFill>
-                <a:latin typeface="Calibri"/>
-              </a:rPr>
-              <a:t>Muestra ~3 meses; baja frecuencia en YM.</a:t>
-            </a:r>
-          </a:p>
-          <a:p>
-            <a:pPr algn="l">
-              <a:spcBef>
-                <a:spcPts val="0"/>
-              </a:spcBef>
-              <a:spcAft>
-                <a:spcPts val="1000"/>
-              </a:spcAft>
-            </a:pPr>
-            <a:r>
-              <a:rPr sz="1500" b="0" i="0">
-                <a:solidFill>
-                  <a:srgbClr val="222222"/>
-                </a:solidFill>
-                <a:latin typeface="Calibri"/>
-              </a:rPr>
-              <a:t>Demo ≠ ejecución real (fills de límites).</a:t>
-            </a:r>
-          </a:p>
-          <a:p>
-            <a:pPr algn="l">
+            <a:pPr algn="ctr">
               <a:spcBef>
                 <a:spcPts val="0"/>
               </a:spcBef>
@@ -3516,13 +3460,13 @@
               </a:spcAft>
             </a:pPr>
             <a:r>
-              <a:rPr sz="1500" b="0" i="0">
+              <a:rPr sz="1400" b="0" i="0">
                 <a:solidFill>
                   <a:srgbClr val="222222"/>
                 </a:solidFill>
                 <a:latin typeface="Calibri"/>
               </a:rPr>
-              <a:t>Estrategias dependientes del proveedor de señal.</a:t>
+              <a:t>estrategias en TradersPost (demo)</a:t>
             </a:r>
           </a:p>
         </p:txBody>
@@ -3535,8 +3479,8 @@
         </p:nvSpPr>
         <p:spPr>
           <a:xfrm>
-            <a:off x="6172200" y="1737360"/>
-            <a:ext cx="5394960" cy="4114800"/>
+            <a:off x="4389120" y="1828800"/>
+            <a:ext cx="3520440" cy="2011680"/>
           </a:xfrm>
           <a:prstGeom prst="roundRect">
             <a:avLst/>
@@ -3579,8 +3523,8 @@
         </p:nvSpPr>
         <p:spPr>
           <a:xfrm>
-            <a:off x="6446520" y="1965960"/>
-            <a:ext cx="4937760" cy="548640"/>
+            <a:off x="4389120" y="2057400"/>
+            <a:ext cx="3520440" cy="1005840"/>
           </a:xfrm>
           <a:prstGeom prst="rect">
             <a:avLst/>
@@ -3592,6 +3536,256 @@
             <a:spAutoFit/>
           </a:bodyPr>
           <a:lstStyle/>
+          <a:p>
+            <a:pPr algn="ctr">
+              <a:spcBef>
+                <a:spcPts val="0"/>
+              </a:spcBef>
+              <a:spcAft>
+                <a:spcPts val="200"/>
+              </a:spcAft>
+            </a:pPr>
+            <a:r>
+              <a:rPr sz="4600" b="1" i="0">
+                <a:solidFill>
+                  <a:srgbClr val="1E2761"/>
+                </a:solidFill>
+                <a:latin typeface="Cambria"/>
+              </a:rPr>
+              <a:t>100%</a:t>
+            </a:r>
+          </a:p>
+        </p:txBody>
+      </p:sp>
+      <p:sp>
+        <p:nvSpPr>
+          <p:cNvPr id="8" name="TextBox 7"/>
+          <p:cNvSpPr txBox="1"/>
+          <p:nvPr/>
+        </p:nvSpPr>
+        <p:spPr>
+          <a:xfrm>
+            <a:off x="4572000" y="3154680"/>
+            <a:ext cx="3154680" cy="640080"/>
+          </a:xfrm>
+          <a:prstGeom prst="rect">
+            <a:avLst/>
+          </a:prstGeom>
+          <a:noFill/>
+        </p:spPr>
+        <p:txBody>
+          <a:bodyPr wrap="square" anchor="t">
+            <a:spAutoFit/>
+          </a:bodyPr>
+          <a:lstStyle/>
+          <a:p>
+            <a:pPr algn="ctr">
+              <a:spcBef>
+                <a:spcPts val="0"/>
+              </a:spcBef>
+              <a:spcAft>
+                <a:spcPts val="200"/>
+              </a:spcAft>
+            </a:pPr>
+            <a:r>
+              <a:rPr sz="1400" b="0" i="0">
+                <a:solidFill>
+                  <a:srgbClr val="222222"/>
+                </a:solidFill>
+                <a:latin typeface="Calibri"/>
+              </a:rPr>
+              <a:t>en paper — sin capital real</a:t>
+            </a:r>
+          </a:p>
+        </p:txBody>
+      </p:sp>
+      <p:sp>
+        <p:nvSpPr>
+          <p:cNvPr id="9" name="Rounded Rectangle 8"/>
+          <p:cNvSpPr/>
+          <p:nvPr/>
+        </p:nvSpPr>
+        <p:spPr>
+          <a:xfrm>
+            <a:off x="8138159" y="1828800"/>
+            <a:ext cx="3520440" cy="2011680"/>
+          </a:xfrm>
+          <a:prstGeom prst="roundRect">
+            <a:avLst/>
+          </a:prstGeom>
+          <a:solidFill>
+            <a:srgbClr val="F1F4FB"/>
+          </a:solidFill>
+          <a:ln>
+            <a:noFill/>
+          </a:ln>
+          <a:effectLst/>
+        </p:spPr>
+        <p:style>
+          <a:lnRef idx="1">
+            <a:schemeClr val="accent1"/>
+          </a:lnRef>
+          <a:fillRef idx="3">
+            <a:schemeClr val="accent1"/>
+          </a:fillRef>
+          <a:effectRef idx="2">
+            <a:schemeClr val="accent1"/>
+          </a:effectRef>
+          <a:fontRef idx="minor">
+            <a:schemeClr val="lt1"/>
+          </a:fontRef>
+        </p:style>
+        <p:txBody>
+          <a:bodyPr rtlCol="0" anchor="ctr"/>
+          <a:lstStyle/>
+          <a:p>
+            <a:pPr algn="ctr"/>
+          </a:p>
+        </p:txBody>
+      </p:sp>
+      <p:sp>
+        <p:nvSpPr>
+          <p:cNvPr id="10" name="TextBox 9"/>
+          <p:cNvSpPr txBox="1"/>
+          <p:nvPr/>
+        </p:nvSpPr>
+        <p:spPr>
+          <a:xfrm>
+            <a:off x="8138159" y="2057400"/>
+            <a:ext cx="3520440" cy="1005840"/>
+          </a:xfrm>
+          <a:prstGeom prst="rect">
+            <a:avLst/>
+          </a:prstGeom>
+          <a:noFill/>
+        </p:spPr>
+        <p:txBody>
+          <a:bodyPr wrap="square" anchor="t">
+            <a:spAutoFit/>
+          </a:bodyPr>
+          <a:lstStyle/>
+          <a:p>
+            <a:pPr algn="ctr">
+              <a:spcBef>
+                <a:spcPts val="0"/>
+              </a:spcBef>
+              <a:spcAft>
+                <a:spcPts val="200"/>
+              </a:spcAft>
+            </a:pPr>
+            <a:r>
+              <a:rPr sz="4600" b="1" i="0">
+                <a:solidFill>
+                  <a:srgbClr val="1E2761"/>
+                </a:solidFill>
+                <a:latin typeface="Cambria"/>
+              </a:rPr>
+              <a:t>✓</a:t>
+            </a:r>
+          </a:p>
+        </p:txBody>
+      </p:sp>
+      <p:sp>
+        <p:nvSpPr>
+          <p:cNvPr id="11" name="TextBox 10"/>
+          <p:cNvSpPr txBox="1"/>
+          <p:nvPr/>
+        </p:nvSpPr>
+        <p:spPr>
+          <a:xfrm>
+            <a:off x="8321039" y="3154680"/>
+            <a:ext cx="3154680" cy="640080"/>
+          </a:xfrm>
+          <a:prstGeom prst="rect">
+            <a:avLst/>
+          </a:prstGeom>
+          <a:noFill/>
+        </p:spPr>
+        <p:txBody>
+          <a:bodyPr wrap="square" anchor="t">
+            <a:spAutoFit/>
+          </a:bodyPr>
+          <a:lstStyle/>
+          <a:p>
+            <a:pPr algn="ctr">
+              <a:spcBef>
+                <a:spcPts val="0"/>
+              </a:spcBef>
+              <a:spcAft>
+                <a:spcPts val="200"/>
+              </a:spcAft>
+            </a:pPr>
+            <a:r>
+              <a:rPr sz="1400" b="0" i="0">
+                <a:solidFill>
+                  <a:srgbClr val="222222"/>
+                </a:solidFill>
+                <a:latin typeface="Calibri"/>
+              </a:rPr>
+              <a:t>escalonado + filtros activos</a:t>
+            </a:r>
+          </a:p>
+        </p:txBody>
+      </p:sp>
+      <p:sp>
+        <p:nvSpPr>
+          <p:cNvPr id="12" name="TextBox 11"/>
+          <p:cNvSpPr txBox="1"/>
+          <p:nvPr/>
+        </p:nvSpPr>
+        <p:spPr>
+          <a:xfrm>
+            <a:off x="640080" y="4297680"/>
+            <a:ext cx="10972800" cy="1463040"/>
+          </a:xfrm>
+          <a:prstGeom prst="rect">
+            <a:avLst/>
+          </a:prstGeom>
+          <a:noFill/>
+        </p:spPr>
+        <p:txBody>
+          <a:bodyPr wrap="square" anchor="t">
+            <a:spAutoFit/>
+          </a:bodyPr>
+          <a:lstStyle/>
+          <a:p>
+            <a:pPr algn="l">
+              <a:spcBef>
+                <a:spcPts val="0"/>
+              </a:spcBef>
+              <a:spcAft>
+                <a:spcPts val="800"/>
+              </a:spcAft>
+            </a:pPr>
+            <a:r>
+              <a:rPr sz="1600" b="0" i="0">
+                <a:solidFill>
+                  <a:srgbClr val="222222"/>
+                </a:solidFill>
+                <a:latin typeface="Calibri"/>
+              </a:rPr>
+              <a:t>Resultados validados contra los backtests originales (Anexos 20 y 22).</a:t>
+            </a:r>
+          </a:p>
+          <a:p>
+            <a:pPr algn="l">
+              <a:spcBef>
+                <a:spcPts val="0"/>
+              </a:spcBef>
+              <a:spcAft>
+                <a:spcPts val="800"/>
+              </a:spcAft>
+            </a:pPr>
+            <a:r>
+              <a:rPr sz="1600" b="0" i="0">
+                <a:solidFill>
+                  <a:srgbClr val="222222"/>
+                </a:solidFill>
+                <a:latin typeface="Calibri"/>
+              </a:rPr>
+              <a:t>Calibración por estrategia (SL, ventana, ATR, escalado) auditable y reversible.</a:t>
+            </a:r>
+          </a:p>
           <a:p>
             <a:pPr algn="l">
               <a:spcBef>
@@ -3602,112 +3796,13 @@
               </a:spcAft>
             </a:pPr>
             <a:r>
-              <a:rPr sz="1800" b="1" i="0">
-                <a:solidFill>
-                  <a:srgbClr val="1F7A4B"/>
+              <a:rPr sz="1600" b="0" i="0">
+                <a:solidFill>
+                  <a:srgbClr val="222222"/>
                 </a:solidFill>
                 <a:latin typeface="Calibri"/>
               </a:rPr>
-              <a:t>Salvaguardas</a:t>
-            </a:r>
-          </a:p>
-        </p:txBody>
-      </p:sp>
-      <p:sp>
-        <p:nvSpPr>
-          <p:cNvPr id="8" name="TextBox 7"/>
-          <p:cNvSpPr txBox="1"/>
-          <p:nvPr/>
-        </p:nvSpPr>
-        <p:spPr>
-          <a:xfrm>
-            <a:off x="6446520" y="2697480"/>
-            <a:ext cx="4937760" cy="3108960"/>
-          </a:xfrm>
-          <a:prstGeom prst="rect">
-            <a:avLst/>
-          </a:prstGeom>
-          <a:noFill/>
-        </p:spPr>
-        <p:txBody>
-          <a:bodyPr wrap="square" anchor="t">
-            <a:spAutoFit/>
-          </a:bodyPr>
-          <a:lstStyle/>
-          <a:p>
-            <a:pPr algn="l">
-              <a:spcBef>
-                <a:spcPts val="0"/>
-              </a:spcBef>
-              <a:spcAft>
-                <a:spcPts val="1000"/>
-              </a:spcAft>
-            </a:pPr>
-            <a:r>
-              <a:rPr sz="1500" b="0" i="0">
-                <a:solidFill>
-                  <a:srgbClr val="222222"/>
-                </a:solidFill>
-                <a:latin typeface="Calibri"/>
-              </a:rPr>
-              <a:t>Dry-run por defecto; envío real sólo con triple gate.</a:t>
-            </a:r>
-          </a:p>
-          <a:p>
-            <a:pPr algn="l">
-              <a:spcBef>
-                <a:spcPts val="0"/>
-              </a:spcBef>
-              <a:spcAft>
-                <a:spcPts val="1000"/>
-              </a:spcAft>
-            </a:pPr>
-            <a:r>
-              <a:rPr sz="1500" b="0" i="0">
-                <a:solidFill>
-                  <a:srgbClr val="222222"/>
-                </a:solidFill>
-                <a:latin typeface="Calibri"/>
-              </a:rPr>
-              <a:t>Backups + auditoría de cada cambio.</a:t>
-            </a:r>
-          </a:p>
-          <a:p>
-            <a:pPr algn="l">
-              <a:spcBef>
-                <a:spcPts val="0"/>
-              </a:spcBef>
-              <a:spcAft>
-                <a:spcPts val="1000"/>
-              </a:spcAft>
-            </a:pPr>
-            <a:r>
-              <a:rPr sz="1500" b="0" i="0">
-                <a:solidFill>
-                  <a:srgbClr val="222222"/>
-                </a:solidFill>
-                <a:latin typeface="Calibri"/>
-              </a:rPr>
-              <a:t>Reversión total en un comando.</a:t>
-            </a:r>
-          </a:p>
-          <a:p>
-            <a:pPr algn="l">
-              <a:spcBef>
-                <a:spcPts val="0"/>
-              </a:spcBef>
-              <a:spcAft>
-                <a:spcPts val="200"/>
-              </a:spcAft>
-            </a:pPr>
-            <a:r>
-              <a:rPr sz="1500" b="0" i="0">
-                <a:solidFill>
-                  <a:srgbClr val="222222"/>
-                </a:solidFill>
-                <a:latin typeface="Calibri"/>
-              </a:rPr>
-              <a:t>Kill-switch global; todo en paper hasta aprobar.</a:t>
+              <a:t>Una semana de operación en demo en curso para confirmar fills reales.</a:t>
             </a:r>
           </a:p>
         </p:txBody>
@@ -3721,6 +3816,444 @@
 </file>
 
 <file path=ppt/slides/slide11.xml><?xml version="1.0" encoding="utf-8"?>
+<p:sld xmlns:a="http://schemas.openxmlformats.org/drawingml/2006/main" xmlns:p="http://schemas.openxmlformats.org/presentationml/2006/main" xmlns:r="http://schemas.openxmlformats.org/officeDocument/2006/relationships">
+  <p:cSld>
+    <p:bg>
+      <p:bgPr>
+        <a:solidFill>
+          <a:srgbClr val="FFFFFF"/>
+        </a:solidFill>
+        <a:effectLst/>
+      </p:bgPr>
+    </p:bg>
+    <p:spTree>
+      <p:nvGrpSpPr>
+        <p:cNvPr id="1" name=""/>
+        <p:cNvGrpSpPr/>
+        <p:nvPr/>
+      </p:nvGrpSpPr>
+      <p:grpSpPr/>
+      <p:sp>
+        <p:nvSpPr>
+          <p:cNvPr id="2" name="TextBox 1"/>
+          <p:cNvSpPr txBox="1"/>
+          <p:nvPr/>
+        </p:nvSpPr>
+        <p:spPr>
+          <a:xfrm>
+            <a:off x="640080" y="502920"/>
+            <a:ext cx="10972800" cy="822960"/>
+          </a:xfrm>
+          <a:prstGeom prst="rect">
+            <a:avLst/>
+          </a:prstGeom>
+          <a:noFill/>
+        </p:spPr>
+        <p:txBody>
+          <a:bodyPr wrap="square" anchor="t">
+            <a:spAutoFit/>
+          </a:bodyPr>
+          <a:lstStyle/>
+          <a:p>
+            <a:pPr algn="l">
+              <a:spcBef>
+                <a:spcPts val="0"/>
+              </a:spcBef>
+              <a:spcAft>
+                <a:spcPts val="200"/>
+              </a:spcAft>
+            </a:pPr>
+            <a:r>
+              <a:rPr sz="3200" b="1" i="0">
+                <a:solidFill>
+                  <a:srgbClr val="1E2761"/>
+                </a:solidFill>
+                <a:latin typeface="Cambria"/>
+              </a:rPr>
+              <a:t>Riesgos y salvaguardas</a:t>
+            </a:r>
+          </a:p>
+        </p:txBody>
+      </p:sp>
+      <p:sp>
+        <p:nvSpPr>
+          <p:cNvPr id="3" name="Rounded Rectangle 2"/>
+          <p:cNvSpPr/>
+          <p:nvPr/>
+        </p:nvSpPr>
+        <p:spPr>
+          <a:xfrm>
+            <a:off x="640080" y="1737360"/>
+            <a:ext cx="5394960" cy="4114800"/>
+          </a:xfrm>
+          <a:prstGeom prst="roundRect">
+            <a:avLst/>
+          </a:prstGeom>
+          <a:solidFill>
+            <a:srgbClr val="F1F4FB"/>
+          </a:solidFill>
+          <a:ln>
+            <a:noFill/>
+          </a:ln>
+          <a:effectLst/>
+        </p:spPr>
+        <p:style>
+          <a:lnRef idx="1">
+            <a:schemeClr val="accent1"/>
+          </a:lnRef>
+          <a:fillRef idx="3">
+            <a:schemeClr val="accent1"/>
+          </a:fillRef>
+          <a:effectRef idx="2">
+            <a:schemeClr val="accent1"/>
+          </a:effectRef>
+          <a:fontRef idx="minor">
+            <a:schemeClr val="lt1"/>
+          </a:fontRef>
+        </p:style>
+        <p:txBody>
+          <a:bodyPr rtlCol="0" anchor="ctr"/>
+          <a:lstStyle/>
+          <a:p>
+            <a:pPr algn="ctr"/>
+          </a:p>
+        </p:txBody>
+      </p:sp>
+      <p:sp>
+        <p:nvSpPr>
+          <p:cNvPr id="4" name="TextBox 3"/>
+          <p:cNvSpPr txBox="1"/>
+          <p:nvPr/>
+        </p:nvSpPr>
+        <p:spPr>
+          <a:xfrm>
+            <a:off x="914400" y="1965960"/>
+            <a:ext cx="4937760" cy="548640"/>
+          </a:xfrm>
+          <a:prstGeom prst="rect">
+            <a:avLst/>
+          </a:prstGeom>
+          <a:noFill/>
+        </p:spPr>
+        <p:txBody>
+          <a:bodyPr wrap="square" anchor="t">
+            <a:spAutoFit/>
+          </a:bodyPr>
+          <a:lstStyle/>
+          <a:p>
+            <a:pPr algn="l">
+              <a:spcBef>
+                <a:spcPts val="0"/>
+              </a:spcBef>
+              <a:spcAft>
+                <a:spcPts val="200"/>
+              </a:spcAft>
+            </a:pPr>
+            <a:r>
+              <a:rPr sz="1800" b="1" i="0">
+                <a:solidFill>
+                  <a:srgbClr val="F96167"/>
+                </a:solidFill>
+                <a:latin typeface="Calibri"/>
+              </a:rPr>
+              <a:t>Riesgos</a:t>
+            </a:r>
+          </a:p>
+        </p:txBody>
+      </p:sp>
+      <p:sp>
+        <p:nvSpPr>
+          <p:cNvPr id="5" name="TextBox 4"/>
+          <p:cNvSpPr txBox="1"/>
+          <p:nvPr/>
+        </p:nvSpPr>
+        <p:spPr>
+          <a:xfrm>
+            <a:off x="914400" y="2697480"/>
+            <a:ext cx="4937760" cy="3108960"/>
+          </a:xfrm>
+          <a:prstGeom prst="rect">
+            <a:avLst/>
+          </a:prstGeom>
+          <a:noFill/>
+        </p:spPr>
+        <p:txBody>
+          <a:bodyPr wrap="square" anchor="t">
+            <a:spAutoFit/>
+          </a:bodyPr>
+          <a:lstStyle/>
+          <a:p>
+            <a:pPr algn="l">
+              <a:spcBef>
+                <a:spcPts val="0"/>
+              </a:spcBef>
+              <a:spcAft>
+                <a:spcPts val="1000"/>
+              </a:spcAft>
+            </a:pPr>
+            <a:r>
+              <a:rPr sz="1500" b="0" i="0">
+                <a:solidFill>
+                  <a:srgbClr val="222222"/>
+                </a:solidFill>
+                <a:latin typeface="Calibri"/>
+              </a:rPr>
+              <a:t>Backtest sin comisiones ni slippage.</a:t>
+            </a:r>
+          </a:p>
+          <a:p>
+            <a:pPr algn="l">
+              <a:spcBef>
+                <a:spcPts val="0"/>
+              </a:spcBef>
+              <a:spcAft>
+                <a:spcPts val="1000"/>
+              </a:spcAft>
+            </a:pPr>
+            <a:r>
+              <a:rPr sz="1500" b="0" i="0">
+                <a:solidFill>
+                  <a:srgbClr val="222222"/>
+                </a:solidFill>
+                <a:latin typeface="Calibri"/>
+              </a:rPr>
+              <a:t>Muestra ~3 meses; baja frecuencia en YM.</a:t>
+            </a:r>
+          </a:p>
+          <a:p>
+            <a:pPr algn="l">
+              <a:spcBef>
+                <a:spcPts val="0"/>
+              </a:spcBef>
+              <a:spcAft>
+                <a:spcPts val="1000"/>
+              </a:spcAft>
+            </a:pPr>
+            <a:r>
+              <a:rPr sz="1500" b="0" i="0">
+                <a:solidFill>
+                  <a:srgbClr val="222222"/>
+                </a:solidFill>
+                <a:latin typeface="Calibri"/>
+              </a:rPr>
+              <a:t>Demo ≠ ejecución real (fills de límites).</a:t>
+            </a:r>
+          </a:p>
+          <a:p>
+            <a:pPr algn="l">
+              <a:spcBef>
+                <a:spcPts val="0"/>
+              </a:spcBef>
+              <a:spcAft>
+                <a:spcPts val="200"/>
+              </a:spcAft>
+            </a:pPr>
+            <a:r>
+              <a:rPr sz="1500" b="0" i="0">
+                <a:solidFill>
+                  <a:srgbClr val="222222"/>
+                </a:solidFill>
+                <a:latin typeface="Calibri"/>
+              </a:rPr>
+              <a:t>Estrategias dependientes del proveedor de señal.</a:t>
+            </a:r>
+          </a:p>
+        </p:txBody>
+      </p:sp>
+      <p:sp>
+        <p:nvSpPr>
+          <p:cNvPr id="6" name="Rounded Rectangle 5"/>
+          <p:cNvSpPr/>
+          <p:nvPr/>
+        </p:nvSpPr>
+        <p:spPr>
+          <a:xfrm>
+            <a:off x="6172200" y="1737360"/>
+            <a:ext cx="5394960" cy="4114800"/>
+          </a:xfrm>
+          <a:prstGeom prst="roundRect">
+            <a:avLst/>
+          </a:prstGeom>
+          <a:solidFill>
+            <a:srgbClr val="F1F4FB"/>
+          </a:solidFill>
+          <a:ln>
+            <a:noFill/>
+          </a:ln>
+          <a:effectLst/>
+        </p:spPr>
+        <p:style>
+          <a:lnRef idx="1">
+            <a:schemeClr val="accent1"/>
+          </a:lnRef>
+          <a:fillRef idx="3">
+            <a:schemeClr val="accent1"/>
+          </a:fillRef>
+          <a:effectRef idx="2">
+            <a:schemeClr val="accent1"/>
+          </a:effectRef>
+          <a:fontRef idx="minor">
+            <a:schemeClr val="lt1"/>
+          </a:fontRef>
+        </p:style>
+        <p:txBody>
+          <a:bodyPr rtlCol="0" anchor="ctr"/>
+          <a:lstStyle/>
+          <a:p>
+            <a:pPr algn="ctr"/>
+          </a:p>
+        </p:txBody>
+      </p:sp>
+      <p:sp>
+        <p:nvSpPr>
+          <p:cNvPr id="7" name="TextBox 6"/>
+          <p:cNvSpPr txBox="1"/>
+          <p:nvPr/>
+        </p:nvSpPr>
+        <p:spPr>
+          <a:xfrm>
+            <a:off x="6446520" y="1965960"/>
+            <a:ext cx="4937760" cy="548640"/>
+          </a:xfrm>
+          <a:prstGeom prst="rect">
+            <a:avLst/>
+          </a:prstGeom>
+          <a:noFill/>
+        </p:spPr>
+        <p:txBody>
+          <a:bodyPr wrap="square" anchor="t">
+            <a:spAutoFit/>
+          </a:bodyPr>
+          <a:lstStyle/>
+          <a:p>
+            <a:pPr algn="l">
+              <a:spcBef>
+                <a:spcPts val="0"/>
+              </a:spcBef>
+              <a:spcAft>
+                <a:spcPts val="200"/>
+              </a:spcAft>
+            </a:pPr>
+            <a:r>
+              <a:rPr sz="1800" b="1" i="0">
+                <a:solidFill>
+                  <a:srgbClr val="1F7A4B"/>
+                </a:solidFill>
+                <a:latin typeface="Calibri"/>
+              </a:rPr>
+              <a:t>Salvaguardas</a:t>
+            </a:r>
+          </a:p>
+        </p:txBody>
+      </p:sp>
+      <p:sp>
+        <p:nvSpPr>
+          <p:cNvPr id="8" name="TextBox 7"/>
+          <p:cNvSpPr txBox="1"/>
+          <p:nvPr/>
+        </p:nvSpPr>
+        <p:spPr>
+          <a:xfrm>
+            <a:off x="6446520" y="2697480"/>
+            <a:ext cx="4937760" cy="3108960"/>
+          </a:xfrm>
+          <a:prstGeom prst="rect">
+            <a:avLst/>
+          </a:prstGeom>
+          <a:noFill/>
+        </p:spPr>
+        <p:txBody>
+          <a:bodyPr wrap="square" anchor="t">
+            <a:spAutoFit/>
+          </a:bodyPr>
+          <a:lstStyle/>
+          <a:p>
+            <a:pPr algn="l">
+              <a:spcBef>
+                <a:spcPts val="0"/>
+              </a:spcBef>
+              <a:spcAft>
+                <a:spcPts val="1000"/>
+              </a:spcAft>
+            </a:pPr>
+            <a:r>
+              <a:rPr sz="1500" b="0" i="0">
+                <a:solidFill>
+                  <a:srgbClr val="222222"/>
+                </a:solidFill>
+                <a:latin typeface="Calibri"/>
+              </a:rPr>
+              <a:t>Dry-run por defecto; envío real sólo con triple gate.</a:t>
+            </a:r>
+          </a:p>
+          <a:p>
+            <a:pPr algn="l">
+              <a:spcBef>
+                <a:spcPts val="0"/>
+              </a:spcBef>
+              <a:spcAft>
+                <a:spcPts val="1000"/>
+              </a:spcAft>
+            </a:pPr>
+            <a:r>
+              <a:rPr sz="1500" b="0" i="0">
+                <a:solidFill>
+                  <a:srgbClr val="222222"/>
+                </a:solidFill>
+                <a:latin typeface="Calibri"/>
+              </a:rPr>
+              <a:t>Backups + auditoría de cada cambio.</a:t>
+            </a:r>
+          </a:p>
+          <a:p>
+            <a:pPr algn="l">
+              <a:spcBef>
+                <a:spcPts val="0"/>
+              </a:spcBef>
+              <a:spcAft>
+                <a:spcPts val="1000"/>
+              </a:spcAft>
+            </a:pPr>
+            <a:r>
+              <a:rPr sz="1500" b="0" i="0">
+                <a:solidFill>
+                  <a:srgbClr val="222222"/>
+                </a:solidFill>
+                <a:latin typeface="Calibri"/>
+              </a:rPr>
+              <a:t>Reversión total en un comando.</a:t>
+            </a:r>
+          </a:p>
+          <a:p>
+            <a:pPr algn="l">
+              <a:spcBef>
+                <a:spcPts val="0"/>
+              </a:spcBef>
+              <a:spcAft>
+                <a:spcPts val="200"/>
+              </a:spcAft>
+            </a:pPr>
+            <a:r>
+              <a:rPr sz="1500" b="0" i="0">
+                <a:solidFill>
+                  <a:srgbClr val="222222"/>
+                </a:solidFill>
+                <a:latin typeface="Calibri"/>
+              </a:rPr>
+              <a:t>Kill-switch global; todo en paper hasta aprobar.</a:t>
+            </a:r>
+          </a:p>
+        </p:txBody>
+      </p:sp>
+    </p:spTree>
+  </p:cSld>
+  <p:clrMapOvr>
+    <a:masterClrMapping/>
+  </p:clrMapOvr>
+</p:sld>
+</file>
+
+<file path=ppt/slides/slide12.xml><?xml version="1.0" encoding="utf-8"?>
 <p:sld xmlns:a="http://schemas.openxmlformats.org/drawingml/2006/main" xmlns:p="http://schemas.openxmlformats.org/presentationml/2006/main" xmlns:r="http://schemas.openxmlformats.org/officeDocument/2006/relationships">
   <p:cSld>
     <p:bg>
@@ -6551,7 +7084,7 @@
                           </a:solidFill>
                           <a:latin typeface="Calibri"/>
                         </a:rPr>
-                        <a:t>ES</a:t>
+                        <a:t>GC</a:t>
                       </a:r>
                     </a:p>
                   </a:txBody>
@@ -6574,7 +7107,7 @@
                           </a:solidFill>
                           <a:latin typeface="Calibri"/>
                         </a:rPr>
-                        <a:t>37 (18/19)</a:t>
+                        <a:t>21 (12/9)</a:t>
                       </a:r>
                     </a:p>
                   </a:txBody>
@@ -6597,7 +7130,7 @@
                           </a:solidFill>
                           <a:latin typeface="Calibri"/>
                         </a:rPr>
-                        <a:t>122 (99/23)</a:t>
+                        <a:t>107 (65/42)</a:t>
                       </a:r>
                     </a:p>
                   </a:txBody>
@@ -6620,7 +7153,7 @@
                           </a:solidFill>
                           <a:latin typeface="Calibri"/>
                         </a:rPr>
-                        <a:t>2.39</a:t>
+                        <a:t>4.91</a:t>
                       </a:r>
                     </a:p>
                   </a:txBody>
@@ -6643,7 +7176,7 @@
                           </a:solidFill>
                           <a:latin typeface="Calibri"/>
                         </a:rPr>
-                        <a:t>1.72</a:t>
+                        <a:t>1.95</a:t>
                       </a:r>
                     </a:p>
                   </a:txBody>
@@ -6666,7 +7199,7 @@
                           </a:solidFill>
                           <a:latin typeface="Calibri"/>
                         </a:rPr>
-                        <a:t>-524</a:t>
+                        <a:t>-549</a:t>
                       </a:r>
                     </a:p>
                   </a:txBody>
@@ -6689,7 +7222,7 @@
                           </a:solidFill>
                           <a:latin typeface="Calibri"/>
                         </a:rPr>
-                        <a:t>-2,032</a:t>
+                        <a:t>-5,878</a:t>
                       </a:r>
                     </a:p>
                   </a:txBody>
@@ -6712,7 +7245,7 @@
                           </a:solidFill>
                           <a:latin typeface="Calibri"/>
                         </a:rPr>
-                        <a:t>5,933</a:t>
+                        <a:t>10,974</a:t>
                       </a:r>
                     </a:p>
                   </a:txBody>
@@ -6735,7 +7268,7 @@
                           </a:solidFill>
                           <a:latin typeface="Calibri"/>
                         </a:rPr>
-                        <a:t>6,448</a:t>
+                        <a:t>27,078</a:t>
                       </a:r>
                     </a:p>
                   </a:txBody>
@@ -6969,6 +7502,424 @@
                           </a:solidFill>
                           <a:latin typeface="Calibri"/>
                         </a:rPr>
+                        <a:t>ES</a:t>
+                      </a:r>
+                    </a:p>
+                  </a:txBody>
+                  <a:tcPr marT="25400" marB="25400" marL="50800" marR="50800">
+                    <a:solidFill>
+                      <a:srgbClr val="F1F4FB"/>
+                    </a:solidFill>
+                  </a:tcPr>
+                </a:tc>
+                <a:tc>
+                  <a:txBody>
+                    <a:bodyPr/>
+                    <a:lstStyle/>
+                    <a:p>
+                      <a:pPr algn="ctr"/>
+                      <a:r>
+                        <a:rPr sz="1100">
+                          <a:solidFill>
+                            <a:srgbClr val="222222"/>
+                          </a:solidFill>
+                          <a:latin typeface="Calibri"/>
+                        </a:rPr>
+                        <a:t>37 (18/19)</a:t>
+                      </a:r>
+                    </a:p>
+                  </a:txBody>
+                  <a:tcPr marT="25400" marB="25400" marL="50800" marR="50800">
+                    <a:solidFill>
+                      <a:srgbClr val="F1F4FB"/>
+                    </a:solidFill>
+                  </a:tcPr>
+                </a:tc>
+                <a:tc>
+                  <a:txBody>
+                    <a:bodyPr/>
+                    <a:lstStyle/>
+                    <a:p>
+                      <a:pPr algn="ctr"/>
+                      <a:r>
+                        <a:rPr sz="1100">
+                          <a:solidFill>
+                            <a:srgbClr val="222222"/>
+                          </a:solidFill>
+                          <a:latin typeface="Calibri"/>
+                        </a:rPr>
+                        <a:t>122 (99/23)</a:t>
+                      </a:r>
+                    </a:p>
+                  </a:txBody>
+                  <a:tcPr marT="25400" marB="25400" marL="50800" marR="50800">
+                    <a:solidFill>
+                      <a:srgbClr val="F1F4FB"/>
+                    </a:solidFill>
+                  </a:tcPr>
+                </a:tc>
+                <a:tc>
+                  <a:txBody>
+                    <a:bodyPr/>
+                    <a:lstStyle/>
+                    <a:p>
+                      <a:pPr algn="ctr"/>
+                      <a:r>
+                        <a:rPr sz="1100" b="1">
+                          <a:solidFill>
+                            <a:srgbClr val="1E2761"/>
+                          </a:solidFill>
+                          <a:latin typeface="Calibri"/>
+                        </a:rPr>
+                        <a:t>2.39</a:t>
+                      </a:r>
+                    </a:p>
+                  </a:txBody>
+                  <a:tcPr marT="25400" marB="25400" marL="50800" marR="50800">
+                    <a:solidFill>
+                      <a:srgbClr val="F1F4FB"/>
+                    </a:solidFill>
+                  </a:tcPr>
+                </a:tc>
+                <a:tc>
+                  <a:txBody>
+                    <a:bodyPr/>
+                    <a:lstStyle/>
+                    <a:p>
+                      <a:pPr algn="ctr"/>
+                      <a:r>
+                        <a:rPr sz="1100">
+                          <a:solidFill>
+                            <a:srgbClr val="222222"/>
+                          </a:solidFill>
+                          <a:latin typeface="Calibri"/>
+                        </a:rPr>
+                        <a:t>1.72</a:t>
+                      </a:r>
+                    </a:p>
+                  </a:txBody>
+                  <a:tcPr marT="25400" marB="25400" marL="50800" marR="50800">
+                    <a:solidFill>
+                      <a:srgbClr val="F1F4FB"/>
+                    </a:solidFill>
+                  </a:tcPr>
+                </a:tc>
+                <a:tc>
+                  <a:txBody>
+                    <a:bodyPr/>
+                    <a:lstStyle/>
+                    <a:p>
+                      <a:pPr algn="ctr"/>
+                      <a:r>
+                        <a:rPr sz="1100">
+                          <a:solidFill>
+                            <a:srgbClr val="222222"/>
+                          </a:solidFill>
+                          <a:latin typeface="Calibri"/>
+                        </a:rPr>
+                        <a:t>-524</a:t>
+                      </a:r>
+                    </a:p>
+                  </a:txBody>
+                  <a:tcPr marT="25400" marB="25400" marL="50800" marR="50800">
+                    <a:solidFill>
+                      <a:srgbClr val="F1F4FB"/>
+                    </a:solidFill>
+                  </a:tcPr>
+                </a:tc>
+                <a:tc>
+                  <a:txBody>
+                    <a:bodyPr/>
+                    <a:lstStyle/>
+                    <a:p>
+                      <a:pPr algn="ctr"/>
+                      <a:r>
+                        <a:rPr sz="1100">
+                          <a:solidFill>
+                            <a:srgbClr val="222222"/>
+                          </a:solidFill>
+                          <a:latin typeface="Calibri"/>
+                        </a:rPr>
+                        <a:t>-2,032</a:t>
+                      </a:r>
+                    </a:p>
+                  </a:txBody>
+                  <a:tcPr marT="25400" marB="25400" marL="50800" marR="50800">
+                    <a:solidFill>
+                      <a:srgbClr val="F1F4FB"/>
+                    </a:solidFill>
+                  </a:tcPr>
+                </a:tc>
+                <a:tc>
+                  <a:txBody>
+                    <a:bodyPr/>
+                    <a:lstStyle/>
+                    <a:p>
+                      <a:pPr algn="ctr"/>
+                      <a:r>
+                        <a:rPr sz="1100">
+                          <a:solidFill>
+                            <a:srgbClr val="222222"/>
+                          </a:solidFill>
+                          <a:latin typeface="Calibri"/>
+                        </a:rPr>
+                        <a:t>5,933</a:t>
+                      </a:r>
+                    </a:p>
+                  </a:txBody>
+                  <a:tcPr marT="25400" marB="25400" marL="50800" marR="50800">
+                    <a:solidFill>
+                      <a:srgbClr val="F1F4FB"/>
+                    </a:solidFill>
+                  </a:tcPr>
+                </a:tc>
+                <a:tc>
+                  <a:txBody>
+                    <a:bodyPr/>
+                    <a:lstStyle/>
+                    <a:p>
+                      <a:pPr algn="ctr"/>
+                      <a:r>
+                        <a:rPr sz="1100">
+                          <a:solidFill>
+                            <a:srgbClr val="222222"/>
+                          </a:solidFill>
+                          <a:latin typeface="Calibri"/>
+                        </a:rPr>
+                        <a:t>6,448</a:t>
+                      </a:r>
+                    </a:p>
+                  </a:txBody>
+                  <a:tcPr marT="25400" marB="25400" marL="50800" marR="50800">
+                    <a:solidFill>
+                      <a:srgbClr val="F1F4FB"/>
+                    </a:solidFill>
+                  </a:tcPr>
+                </a:tc>
+              </a:tr>
+              <a:tr h="438912">
+                <a:tc>
+                  <a:txBody>
+                    <a:bodyPr/>
+                    <a:lstStyle/>
+                    <a:p>
+                      <a:pPr algn="l"/>
+                      <a:r>
+                        <a:rPr sz="1100">
+                          <a:solidFill>
+                            <a:srgbClr val="222222"/>
+                          </a:solidFill>
+                          <a:latin typeface="Calibri"/>
+                        </a:rPr>
+                        <a:t>RTY</a:t>
+                      </a:r>
+                    </a:p>
+                  </a:txBody>
+                  <a:tcPr marT="25400" marB="25400" marL="50800" marR="50800">
+                    <a:solidFill>
+                      <a:srgbClr val="FFFFFF"/>
+                    </a:solidFill>
+                  </a:tcPr>
+                </a:tc>
+                <a:tc>
+                  <a:txBody>
+                    <a:bodyPr/>
+                    <a:lstStyle/>
+                    <a:p>
+                      <a:pPr algn="ctr"/>
+                      <a:r>
+                        <a:rPr sz="1100">
+                          <a:solidFill>
+                            <a:srgbClr val="222222"/>
+                          </a:solidFill>
+                          <a:latin typeface="Calibri"/>
+                        </a:rPr>
+                        <a:t>11 (10/1)</a:t>
+                      </a:r>
+                    </a:p>
+                  </a:txBody>
+                  <a:tcPr marT="25400" marB="25400" marL="50800" marR="50800">
+                    <a:solidFill>
+                      <a:srgbClr val="FFFFFF"/>
+                    </a:solidFill>
+                  </a:tcPr>
+                </a:tc>
+                <a:tc>
+                  <a:txBody>
+                    <a:bodyPr/>
+                    <a:lstStyle/>
+                    <a:p>
+                      <a:pPr algn="ctr"/>
+                      <a:r>
+                        <a:rPr sz="1100">
+                          <a:solidFill>
+                            <a:srgbClr val="222222"/>
+                          </a:solidFill>
+                          <a:latin typeface="Calibri"/>
+                        </a:rPr>
+                        <a:t>112 (97/14)</a:t>
+                      </a:r>
+                    </a:p>
+                  </a:txBody>
+                  <a:tcPr marT="25400" marB="25400" marL="50800" marR="50800">
+                    <a:solidFill>
+                      <a:srgbClr val="FFFFFF"/>
+                    </a:solidFill>
+                  </a:tcPr>
+                </a:tc>
+                <a:tc>
+                  <a:txBody>
+                    <a:bodyPr/>
+                    <a:lstStyle/>
+                    <a:p>
+                      <a:pPr algn="ctr"/>
+                      <a:r>
+                        <a:rPr sz="1100" b="1">
+                          <a:solidFill>
+                            <a:srgbClr val="1E2761"/>
+                          </a:solidFill>
+                          <a:latin typeface="Calibri"/>
+                        </a:rPr>
+                        <a:t>11.55</a:t>
+                      </a:r>
+                    </a:p>
+                  </a:txBody>
+                  <a:tcPr marT="25400" marB="25400" marL="50800" marR="50800">
+                    <a:solidFill>
+                      <a:srgbClr val="FFFFFF"/>
+                    </a:solidFill>
+                  </a:tcPr>
+                </a:tc>
+                <a:tc>
+                  <a:txBody>
+                    <a:bodyPr/>
+                    <a:lstStyle/>
+                    <a:p>
+                      <a:pPr algn="ctr"/>
+                      <a:r>
+                        <a:rPr sz="1100">
+                          <a:solidFill>
+                            <a:srgbClr val="222222"/>
+                          </a:solidFill>
+                          <a:latin typeface="Calibri"/>
+                        </a:rPr>
+                        <a:t>2.15</a:t>
+                      </a:r>
+                    </a:p>
+                  </a:txBody>
+                  <a:tcPr marT="25400" marB="25400" marL="50800" marR="50800">
+                    <a:solidFill>
+                      <a:srgbClr val="FFFFFF"/>
+                    </a:solidFill>
+                  </a:tcPr>
+                </a:tc>
+                <a:tc>
+                  <a:txBody>
+                    <a:bodyPr/>
+                    <a:lstStyle/>
+                    <a:p>
+                      <a:pPr algn="ctr"/>
+                      <a:r>
+                        <a:rPr sz="1100">
+                          <a:solidFill>
+                            <a:srgbClr val="222222"/>
+                          </a:solidFill>
+                          <a:latin typeface="Calibri"/>
+                        </a:rPr>
+                        <a:t>-290</a:t>
+                      </a:r>
+                    </a:p>
+                  </a:txBody>
+                  <a:tcPr marT="25400" marB="25400" marL="50800" marR="50800">
+                    <a:solidFill>
+                      <a:srgbClr val="FFFFFF"/>
+                    </a:solidFill>
+                  </a:tcPr>
+                </a:tc>
+                <a:tc>
+                  <a:txBody>
+                    <a:bodyPr/>
+                    <a:lstStyle/>
+                    <a:p>
+                      <a:pPr algn="ctr"/>
+                      <a:r>
+                        <a:rPr sz="1100">
+                          <a:solidFill>
+                            <a:srgbClr val="222222"/>
+                          </a:solidFill>
+                          <a:latin typeface="Calibri"/>
+                        </a:rPr>
+                        <a:t>-1,483</a:t>
+                      </a:r>
+                    </a:p>
+                  </a:txBody>
+                  <a:tcPr marT="25400" marB="25400" marL="50800" marR="50800">
+                    <a:solidFill>
+                      <a:srgbClr val="FFFFFF"/>
+                    </a:solidFill>
+                  </a:tcPr>
+                </a:tc>
+                <a:tc>
+                  <a:txBody>
+                    <a:bodyPr/>
+                    <a:lstStyle/>
+                    <a:p>
+                      <a:pPr algn="ctr"/>
+                      <a:r>
+                        <a:rPr sz="1100">
+                          <a:solidFill>
+                            <a:srgbClr val="222222"/>
+                          </a:solidFill>
+                          <a:latin typeface="Calibri"/>
+                        </a:rPr>
+                        <a:t>3,054</a:t>
+                      </a:r>
+                    </a:p>
+                  </a:txBody>
+                  <a:tcPr marT="25400" marB="25400" marL="50800" marR="50800">
+                    <a:solidFill>
+                      <a:srgbClr val="FFFFFF"/>
+                    </a:solidFill>
+                  </a:tcPr>
+                </a:tc>
+                <a:tc>
+                  <a:txBody>
+                    <a:bodyPr/>
+                    <a:lstStyle/>
+                    <a:p>
+                      <a:pPr algn="ctr"/>
+                      <a:r>
+                        <a:rPr sz="1100">
+                          <a:solidFill>
+                            <a:srgbClr val="222222"/>
+                          </a:solidFill>
+                          <a:latin typeface="Calibri"/>
+                        </a:rPr>
+                        <a:t>8,924</a:t>
+                      </a:r>
+                    </a:p>
+                  </a:txBody>
+                  <a:tcPr marT="25400" marB="25400" marL="50800" marR="50800">
+                    <a:solidFill>
+                      <a:srgbClr val="FFFFFF"/>
+                    </a:solidFill>
+                  </a:tcPr>
+                </a:tc>
+              </a:tr>
+              <a:tr h="438912">
+                <a:tc>
+                  <a:txBody>
+                    <a:bodyPr/>
+                    <a:lstStyle/>
+                    <a:p>
+                      <a:pPr algn="l"/>
+                      <a:r>
+                        <a:rPr sz="1100">
+                          <a:solidFill>
+                            <a:srgbClr val="222222"/>
+                          </a:solidFill>
+                          <a:latin typeface="Calibri"/>
+                        </a:rPr>
                         <a:t>YM</a:t>
                       </a:r>
                     </a:p>
@@ -7154,424 +8105,6 @@
                           <a:latin typeface="Calibri"/>
                         </a:rPr>
                         <a:t>4,538</a:t>
-                      </a:r>
-                    </a:p>
-                  </a:txBody>
-                  <a:tcPr marT="25400" marB="25400" marL="50800" marR="50800">
-                    <a:solidFill>
-                      <a:srgbClr val="F1F4FB"/>
-                    </a:solidFill>
-                  </a:tcPr>
-                </a:tc>
-              </a:tr>
-              <a:tr h="438912">
-                <a:tc>
-                  <a:txBody>
-                    <a:bodyPr/>
-                    <a:lstStyle/>
-                    <a:p>
-                      <a:pPr algn="l"/>
-                      <a:r>
-                        <a:rPr sz="1100">
-                          <a:solidFill>
-                            <a:srgbClr val="222222"/>
-                          </a:solidFill>
-                          <a:latin typeface="Calibri"/>
-                        </a:rPr>
-                        <a:t>GC</a:t>
-                      </a:r>
-                    </a:p>
-                  </a:txBody>
-                  <a:tcPr marT="25400" marB="25400" marL="50800" marR="50800">
-                    <a:solidFill>
-                      <a:srgbClr val="FFFFFF"/>
-                    </a:solidFill>
-                  </a:tcPr>
-                </a:tc>
-                <a:tc>
-                  <a:txBody>
-                    <a:bodyPr/>
-                    <a:lstStyle/>
-                    <a:p>
-                      <a:pPr algn="ctr"/>
-                      <a:r>
-                        <a:rPr sz="1100">
-                          <a:solidFill>
-                            <a:srgbClr val="222222"/>
-                          </a:solidFill>
-                          <a:latin typeface="Calibri"/>
-                        </a:rPr>
-                        <a:t>21 (12/9)</a:t>
-                      </a:r>
-                    </a:p>
-                  </a:txBody>
-                  <a:tcPr marT="25400" marB="25400" marL="50800" marR="50800">
-                    <a:solidFill>
-                      <a:srgbClr val="FFFFFF"/>
-                    </a:solidFill>
-                  </a:tcPr>
-                </a:tc>
-                <a:tc>
-                  <a:txBody>
-                    <a:bodyPr/>
-                    <a:lstStyle/>
-                    <a:p>
-                      <a:pPr algn="ctr"/>
-                      <a:r>
-                        <a:rPr sz="1100">
-                          <a:solidFill>
-                            <a:srgbClr val="222222"/>
-                          </a:solidFill>
-                          <a:latin typeface="Calibri"/>
-                        </a:rPr>
-                        <a:t>107 (65/42)</a:t>
-                      </a:r>
-                    </a:p>
-                  </a:txBody>
-                  <a:tcPr marT="25400" marB="25400" marL="50800" marR="50800">
-                    <a:solidFill>
-                      <a:srgbClr val="FFFFFF"/>
-                    </a:solidFill>
-                  </a:tcPr>
-                </a:tc>
-                <a:tc>
-                  <a:txBody>
-                    <a:bodyPr/>
-                    <a:lstStyle/>
-                    <a:p>
-                      <a:pPr algn="ctr"/>
-                      <a:r>
-                        <a:rPr sz="1100" b="1">
-                          <a:solidFill>
-                            <a:srgbClr val="1E2761"/>
-                          </a:solidFill>
-                          <a:latin typeface="Calibri"/>
-                        </a:rPr>
-                        <a:t>4.91</a:t>
-                      </a:r>
-                    </a:p>
-                  </a:txBody>
-                  <a:tcPr marT="25400" marB="25400" marL="50800" marR="50800">
-                    <a:solidFill>
-                      <a:srgbClr val="FFFFFF"/>
-                    </a:solidFill>
-                  </a:tcPr>
-                </a:tc>
-                <a:tc>
-                  <a:txBody>
-                    <a:bodyPr/>
-                    <a:lstStyle/>
-                    <a:p>
-                      <a:pPr algn="ctr"/>
-                      <a:r>
-                        <a:rPr sz="1100">
-                          <a:solidFill>
-                            <a:srgbClr val="222222"/>
-                          </a:solidFill>
-                          <a:latin typeface="Calibri"/>
-                        </a:rPr>
-                        <a:t>1.95</a:t>
-                      </a:r>
-                    </a:p>
-                  </a:txBody>
-                  <a:tcPr marT="25400" marB="25400" marL="50800" marR="50800">
-                    <a:solidFill>
-                      <a:srgbClr val="FFFFFF"/>
-                    </a:solidFill>
-                  </a:tcPr>
-                </a:tc>
-                <a:tc>
-                  <a:txBody>
-                    <a:bodyPr/>
-                    <a:lstStyle/>
-                    <a:p>
-                      <a:pPr algn="ctr"/>
-                      <a:r>
-                        <a:rPr sz="1100">
-                          <a:solidFill>
-                            <a:srgbClr val="222222"/>
-                          </a:solidFill>
-                          <a:latin typeface="Calibri"/>
-                        </a:rPr>
-                        <a:t>-549</a:t>
-                      </a:r>
-                    </a:p>
-                  </a:txBody>
-                  <a:tcPr marT="25400" marB="25400" marL="50800" marR="50800">
-                    <a:solidFill>
-                      <a:srgbClr val="FFFFFF"/>
-                    </a:solidFill>
-                  </a:tcPr>
-                </a:tc>
-                <a:tc>
-                  <a:txBody>
-                    <a:bodyPr/>
-                    <a:lstStyle/>
-                    <a:p>
-                      <a:pPr algn="ctr"/>
-                      <a:r>
-                        <a:rPr sz="1100">
-                          <a:solidFill>
-                            <a:srgbClr val="222222"/>
-                          </a:solidFill>
-                          <a:latin typeface="Calibri"/>
-                        </a:rPr>
-                        <a:t>-5,878</a:t>
-                      </a:r>
-                    </a:p>
-                  </a:txBody>
-                  <a:tcPr marT="25400" marB="25400" marL="50800" marR="50800">
-                    <a:solidFill>
-                      <a:srgbClr val="FFFFFF"/>
-                    </a:solidFill>
-                  </a:tcPr>
-                </a:tc>
-                <a:tc>
-                  <a:txBody>
-                    <a:bodyPr/>
-                    <a:lstStyle/>
-                    <a:p>
-                      <a:pPr algn="ctr"/>
-                      <a:r>
-                        <a:rPr sz="1100">
-                          <a:solidFill>
-                            <a:srgbClr val="222222"/>
-                          </a:solidFill>
-                          <a:latin typeface="Calibri"/>
-                        </a:rPr>
-                        <a:t>10,974</a:t>
-                      </a:r>
-                    </a:p>
-                  </a:txBody>
-                  <a:tcPr marT="25400" marB="25400" marL="50800" marR="50800">
-                    <a:solidFill>
-                      <a:srgbClr val="FFFFFF"/>
-                    </a:solidFill>
-                  </a:tcPr>
-                </a:tc>
-                <a:tc>
-                  <a:txBody>
-                    <a:bodyPr/>
-                    <a:lstStyle/>
-                    <a:p>
-                      <a:pPr algn="ctr"/>
-                      <a:r>
-                        <a:rPr sz="1100">
-                          <a:solidFill>
-                            <a:srgbClr val="222222"/>
-                          </a:solidFill>
-                          <a:latin typeface="Calibri"/>
-                        </a:rPr>
-                        <a:t>27,078</a:t>
-                      </a:r>
-                    </a:p>
-                  </a:txBody>
-                  <a:tcPr marT="25400" marB="25400" marL="50800" marR="50800">
-                    <a:solidFill>
-                      <a:srgbClr val="FFFFFF"/>
-                    </a:solidFill>
-                  </a:tcPr>
-                </a:tc>
-              </a:tr>
-              <a:tr h="438912">
-                <a:tc>
-                  <a:txBody>
-                    <a:bodyPr/>
-                    <a:lstStyle/>
-                    <a:p>
-                      <a:pPr algn="l"/>
-                      <a:r>
-                        <a:rPr sz="1100">
-                          <a:solidFill>
-                            <a:srgbClr val="222222"/>
-                          </a:solidFill>
-                          <a:latin typeface="Calibri"/>
-                        </a:rPr>
-                        <a:t>RTY</a:t>
-                      </a:r>
-                    </a:p>
-                  </a:txBody>
-                  <a:tcPr marT="25400" marB="25400" marL="50800" marR="50800">
-                    <a:solidFill>
-                      <a:srgbClr val="F1F4FB"/>
-                    </a:solidFill>
-                  </a:tcPr>
-                </a:tc>
-                <a:tc>
-                  <a:txBody>
-                    <a:bodyPr/>
-                    <a:lstStyle/>
-                    <a:p>
-                      <a:pPr algn="ctr"/>
-                      <a:r>
-                        <a:rPr sz="1100">
-                          <a:solidFill>
-                            <a:srgbClr val="222222"/>
-                          </a:solidFill>
-                          <a:latin typeface="Calibri"/>
-                        </a:rPr>
-                        <a:t>11 (10/1)</a:t>
-                      </a:r>
-                    </a:p>
-                  </a:txBody>
-                  <a:tcPr marT="25400" marB="25400" marL="50800" marR="50800">
-                    <a:solidFill>
-                      <a:srgbClr val="F1F4FB"/>
-                    </a:solidFill>
-                  </a:tcPr>
-                </a:tc>
-                <a:tc>
-                  <a:txBody>
-                    <a:bodyPr/>
-                    <a:lstStyle/>
-                    <a:p>
-                      <a:pPr algn="ctr"/>
-                      <a:r>
-                        <a:rPr sz="1100">
-                          <a:solidFill>
-                            <a:srgbClr val="222222"/>
-                          </a:solidFill>
-                          <a:latin typeface="Calibri"/>
-                        </a:rPr>
-                        <a:t>112 (97/14)</a:t>
-                      </a:r>
-                    </a:p>
-                  </a:txBody>
-                  <a:tcPr marT="25400" marB="25400" marL="50800" marR="50800">
-                    <a:solidFill>
-                      <a:srgbClr val="F1F4FB"/>
-                    </a:solidFill>
-                  </a:tcPr>
-                </a:tc>
-                <a:tc>
-                  <a:txBody>
-                    <a:bodyPr/>
-                    <a:lstStyle/>
-                    <a:p>
-                      <a:pPr algn="ctr"/>
-                      <a:r>
-                        <a:rPr sz="1100" b="1">
-                          <a:solidFill>
-                            <a:srgbClr val="1E2761"/>
-                          </a:solidFill>
-                          <a:latin typeface="Calibri"/>
-                        </a:rPr>
-                        <a:t>11.55</a:t>
-                      </a:r>
-                    </a:p>
-                  </a:txBody>
-                  <a:tcPr marT="25400" marB="25400" marL="50800" marR="50800">
-                    <a:solidFill>
-                      <a:srgbClr val="F1F4FB"/>
-                    </a:solidFill>
-                  </a:tcPr>
-                </a:tc>
-                <a:tc>
-                  <a:txBody>
-                    <a:bodyPr/>
-                    <a:lstStyle/>
-                    <a:p>
-                      <a:pPr algn="ctr"/>
-                      <a:r>
-                        <a:rPr sz="1100">
-                          <a:solidFill>
-                            <a:srgbClr val="222222"/>
-                          </a:solidFill>
-                          <a:latin typeface="Calibri"/>
-                        </a:rPr>
-                        <a:t>2.15</a:t>
-                      </a:r>
-                    </a:p>
-                  </a:txBody>
-                  <a:tcPr marT="25400" marB="25400" marL="50800" marR="50800">
-                    <a:solidFill>
-                      <a:srgbClr val="F1F4FB"/>
-                    </a:solidFill>
-                  </a:tcPr>
-                </a:tc>
-                <a:tc>
-                  <a:txBody>
-                    <a:bodyPr/>
-                    <a:lstStyle/>
-                    <a:p>
-                      <a:pPr algn="ctr"/>
-                      <a:r>
-                        <a:rPr sz="1100">
-                          <a:solidFill>
-                            <a:srgbClr val="222222"/>
-                          </a:solidFill>
-                          <a:latin typeface="Calibri"/>
-                        </a:rPr>
-                        <a:t>-290</a:t>
-                      </a:r>
-                    </a:p>
-                  </a:txBody>
-                  <a:tcPr marT="25400" marB="25400" marL="50800" marR="50800">
-                    <a:solidFill>
-                      <a:srgbClr val="F1F4FB"/>
-                    </a:solidFill>
-                  </a:tcPr>
-                </a:tc>
-                <a:tc>
-                  <a:txBody>
-                    <a:bodyPr/>
-                    <a:lstStyle/>
-                    <a:p>
-                      <a:pPr algn="ctr"/>
-                      <a:r>
-                        <a:rPr sz="1100">
-                          <a:solidFill>
-                            <a:srgbClr val="222222"/>
-                          </a:solidFill>
-                          <a:latin typeface="Calibri"/>
-                        </a:rPr>
-                        <a:t>-1,483</a:t>
-                      </a:r>
-                    </a:p>
-                  </a:txBody>
-                  <a:tcPr marT="25400" marB="25400" marL="50800" marR="50800">
-                    <a:solidFill>
-                      <a:srgbClr val="F1F4FB"/>
-                    </a:solidFill>
-                  </a:tcPr>
-                </a:tc>
-                <a:tc>
-                  <a:txBody>
-                    <a:bodyPr/>
-                    <a:lstStyle/>
-                    <a:p>
-                      <a:pPr algn="ctr"/>
-                      <a:r>
-                        <a:rPr sz="1100">
-                          <a:solidFill>
-                            <a:srgbClr val="222222"/>
-                          </a:solidFill>
-                          <a:latin typeface="Calibri"/>
-                        </a:rPr>
-                        <a:t>3,054</a:t>
-                      </a:r>
-                    </a:p>
-                  </a:txBody>
-                  <a:tcPr marT="25400" marB="25400" marL="50800" marR="50800">
-                    <a:solidFill>
-                      <a:srgbClr val="F1F4FB"/>
-                    </a:solidFill>
-                  </a:tcPr>
-                </a:tc>
-                <a:tc>
-                  <a:txBody>
-                    <a:bodyPr/>
-                    <a:lstStyle/>
-                    <a:p>
-                      <a:pPr algn="ctr"/>
-                      <a:r>
-                        <a:rPr sz="1100">
-                          <a:solidFill>
-                            <a:srgbClr val="222222"/>
-                          </a:solidFill>
-                          <a:latin typeface="Calibri"/>
-                        </a:rPr>
-                        <a:t>8,924</a:t>
                       </a:r>
                     </a:p>
                   </a:txBody>
@@ -8459,7 +8992,7 @@
                 </a:solidFill>
                 <a:latin typeface="Calibri"/>
               </a:rPr>
-              <a:t>USD/micro · A = NTEXECG · B = LuxAlgo 2 micros · Ops = operaciones (Ganadoras/Perdedoras)</a:t>
+              <a:t>Ordenado por Neto $ con NTEXECG · USD/micro · A = NTEXECG · B = LuxAlgo 2 micros · Ops (Ganadoras/Perdedoras)</a:t>
             </a:r>
           </a:p>
         </p:txBody>
@@ -8975,7 +9508,7 @@
         <p:spPr>
           <a:xfrm>
             <a:off x="640080" y="502920"/>
-            <a:ext cx="10972800" cy="822960"/>
+            <a:ext cx="10972800" cy="868680"/>
           </a:xfrm>
           <a:prstGeom prst="rect">
             <a:avLst/>
@@ -8997,13 +9530,13 @@
               </a:spcAft>
             </a:pPr>
             <a:r>
-              <a:rPr sz="3200" b="1" i="0">
+              <a:rPr sz="2900" b="1" i="0">
                 <a:solidFill>
                   <a:srgbClr val="1E2761"/>
                 </a:solidFill>
                 <a:latin typeface="Cambria"/>
               </a:rPr>
-              <a:t>Estado: validado y operando en demo</a:t>
+              <a:t>¿Qué tipo de estrategia rinde mejor con NTEXECG?</a:t>
             </a:r>
           </a:p>
         </p:txBody>
@@ -9016,8 +9549,8 @@
         </p:nvSpPr>
         <p:spPr>
           <a:xfrm>
-            <a:off x="640080" y="1828800"/>
-            <a:ext cx="3520440" cy="2011680"/>
+            <a:off x="640080" y="1645920"/>
+            <a:ext cx="10927080" cy="868680"/>
           </a:xfrm>
           <a:prstGeom prst="roundRect">
             <a:avLst/>
@@ -9060,8 +9593,8 @@
         </p:nvSpPr>
         <p:spPr>
           <a:xfrm>
-            <a:off x="640080" y="2057400"/>
-            <a:ext cx="3520440" cy="1005840"/>
+            <a:off x="868680" y="1783080"/>
+            <a:ext cx="10515600" cy="640080"/>
           </a:xfrm>
           <a:prstGeom prst="rect">
             <a:avLst/>
@@ -9074,7 +9607,7 @@
           </a:bodyPr>
           <a:lstStyle/>
           <a:p>
-            <a:pPr algn="ctr">
+            <a:pPr algn="l">
               <a:spcBef>
                 <a:spcPts val="0"/>
               </a:spcBef>
@@ -9083,75 +9616,33 @@
               </a:spcAft>
             </a:pPr>
             <a:r>
-              <a:rPr sz="4600" b="1" i="0">
+              <a:rPr sz="1500" b="1" i="0">
                 <a:solidFill>
                   <a:srgbClr val="1E2761"/>
                 </a:solidFill>
-                <a:latin typeface="Cambria"/>
-              </a:rPr>
-              <a:t>8</a:t>
-            </a:r>
-          </a:p>
-        </p:txBody>
-      </p:sp>
-      <p:sp>
-        <p:nvSpPr>
-          <p:cNvPr id="5" name="TextBox 4"/>
-          <p:cNvSpPr txBox="1"/>
-          <p:nvPr/>
-        </p:nvSpPr>
-        <p:spPr>
-          <a:xfrm>
-            <a:off x="822959" y="3154680"/>
-            <a:ext cx="3154680" cy="640080"/>
-          </a:xfrm>
-          <a:prstGeom prst="rect">
-            <a:avLst/>
-          </a:prstGeom>
-          <a:noFill/>
-        </p:spPr>
-        <p:txBody>
-          <a:bodyPr wrap="square" anchor="t">
-            <a:spAutoFit/>
-          </a:bodyPr>
-          <a:lstStyle/>
-          <a:p>
-            <a:pPr algn="ctr">
-              <a:spcBef>
-                <a:spcPts val="0"/>
-              </a:spcBef>
-              <a:spcAft>
-                <a:spcPts val="200"/>
-              </a:spcAft>
-            </a:pPr>
-            <a:r>
-              <a:rPr sz="1400" b="0" i="0">
-                <a:solidFill>
-                  <a:srgbClr val="222222"/>
-                </a:solidFill>
                 <a:latin typeface="Calibri"/>
               </a:rPr>
-              <a:t>estrategias en TradersPost (demo)</a:t>
-            </a:r>
-          </a:p>
-        </p:txBody>
-      </p:sp>
-      <p:sp>
-        <p:nvSpPr>
-          <p:cNvPr id="6" name="Rounded Rectangle 5"/>
+              <a:t>Top 4 por resultado neto: GC · NQ · ES · RTY — comparten Confirmación, trailing de tendencia e índices/oro.</a:t>
+            </a:r>
+          </a:p>
+        </p:txBody>
+      </p:sp>
+      <p:sp>
+        <p:nvSpPr>
+          <p:cNvPr id="5" name="Oval 4"/>
           <p:cNvSpPr/>
           <p:nvPr/>
         </p:nvSpPr>
         <p:spPr>
           <a:xfrm>
-            <a:off x="4389120" y="1828800"/>
-            <a:ext cx="3520440" cy="2011680"/>
-          </a:xfrm>
-          <a:prstGeom prst="roundRect">
+            <a:off x="731520" y="2880360"/>
+            <a:ext cx="502920" cy="502920"/>
+          </a:xfrm>
+          <a:prstGeom prst="ellipse">
             <a:avLst/>
           </a:prstGeom>
           <a:solidFill>
-            <a:srgbClr val="F1F4FB"/>
+            <a:srgbClr val="1E2761"/>
           </a:solidFill>
           <a:ln>
             <a:noFill/>
@@ -9173,23 +9664,32 @@
           </a:fontRef>
         </p:style>
         <p:txBody>
-          <a:bodyPr rtlCol="0" anchor="ctr"/>
+          <a:bodyPr rtlCol="0" anchor="ctr" wrap="none"/>
           <a:lstStyle/>
           <a:p>
             <a:pPr algn="ctr"/>
-          </a:p>
-        </p:txBody>
-      </p:sp>
-      <p:sp>
-        <p:nvSpPr>
-          <p:cNvPr id="7" name="TextBox 6"/>
+            <a:r>
+              <a:rPr sz="1100" b="1">
+                <a:solidFill>
+                  <a:srgbClr val="FFFFFF"/>
+                </a:solidFill>
+                <a:latin typeface="Cambria"/>
+              </a:rPr>
+              <a:t>●</a:t>
+            </a:r>
+          </a:p>
+        </p:txBody>
+      </p:sp>
+      <p:sp>
+        <p:nvSpPr>
+          <p:cNvPr id="6" name="TextBox 5"/>
           <p:cNvSpPr txBox="1"/>
           <p:nvPr/>
         </p:nvSpPr>
         <p:spPr>
           <a:xfrm>
-            <a:off x="4389120" y="2057400"/>
-            <a:ext cx="3520440" cy="1005840"/>
+            <a:off x="1463040" y="2852928"/>
+            <a:ext cx="10058400" cy="777240"/>
           </a:xfrm>
           <a:prstGeom prst="rect">
             <a:avLst/>
@@ -9202,7 +9702,26 @@
           </a:bodyPr>
           <a:lstStyle/>
           <a:p>
-            <a:pPr algn="ctr">
+            <a:pPr algn="l">
+              <a:spcBef>
+                <a:spcPts val="0"/>
+              </a:spcBef>
+              <a:spcAft>
+                <a:spcPts val="100"/>
+              </a:spcAft>
+            </a:pPr>
+            <a:r>
+              <a:rPr sz="1700" b="1" i="0">
+                <a:solidFill>
+                  <a:srgbClr val="1E2761"/>
+                </a:solidFill>
+                <a:latin typeface="Calibri"/>
+              </a:rPr>
+              <a:t>Señal</a:t>
+            </a:r>
+          </a:p>
+          <a:p>
+            <a:pPr algn="l">
               <a:spcBef>
                 <a:spcPts val="0"/>
               </a:spcBef>
@@ -9211,75 +9730,33 @@
               </a:spcAft>
             </a:pPr>
             <a:r>
-              <a:rPr sz="4600" b="1" i="0">
-                <a:solidFill>
-                  <a:srgbClr val="1E2761"/>
-                </a:solidFill>
-                <a:latin typeface="Cambria"/>
-              </a:rPr>
-              <a:t>100%</a:t>
-            </a:r>
-          </a:p>
-        </p:txBody>
-      </p:sp>
-      <p:sp>
-        <p:nvSpPr>
-          <p:cNvPr id="8" name="TextBox 7"/>
-          <p:cNvSpPr txBox="1"/>
-          <p:nvPr/>
-        </p:nvSpPr>
-        <p:spPr>
-          <a:xfrm>
-            <a:off x="4572000" y="3154680"/>
-            <a:ext cx="3154680" cy="640080"/>
-          </a:xfrm>
-          <a:prstGeom prst="rect">
-            <a:avLst/>
-          </a:prstGeom>
-          <a:noFill/>
-        </p:spPr>
-        <p:txBody>
-          <a:bodyPr wrap="square" anchor="t">
-            <a:spAutoFit/>
-          </a:bodyPr>
-          <a:lstStyle/>
-          <a:p>
-            <a:pPr algn="ctr">
-              <a:spcBef>
-                <a:spcPts val="0"/>
-              </a:spcBef>
-              <a:spcAft>
-                <a:spcPts val="200"/>
-              </a:spcAft>
-            </a:pPr>
-            <a:r>
               <a:rPr sz="1400" b="0" i="0">
                 <a:solidFill>
                   <a:srgbClr val="222222"/>
                 </a:solidFill>
                 <a:latin typeface="Calibri"/>
               </a:rPr>
-              <a:t>en paper — sin capital real</a:t>
-            </a:r>
-          </a:p>
-        </p:txBody>
-      </p:sp>
-      <p:sp>
-        <p:nvSpPr>
-          <p:cNvPr id="9" name="Rounded Rectangle 8"/>
+              <a:t>Confirmación a favor de tendencia. Contrarian sólo con filtro de calidad + trailing (caso GC).</a:t>
+            </a:r>
+          </a:p>
+        </p:txBody>
+      </p:sp>
+      <p:sp>
+        <p:nvSpPr>
+          <p:cNvPr id="7" name="Oval 6"/>
           <p:cNvSpPr/>
           <p:nvPr/>
         </p:nvSpPr>
         <p:spPr>
           <a:xfrm>
-            <a:off x="8138159" y="1828800"/>
-            <a:ext cx="3520440" cy="2011680"/>
-          </a:xfrm>
-          <a:prstGeom prst="roundRect">
+            <a:off x="731520" y="3721608"/>
+            <a:ext cx="502920" cy="502920"/>
+          </a:xfrm>
+          <a:prstGeom prst="ellipse">
             <a:avLst/>
           </a:prstGeom>
           <a:solidFill>
-            <a:srgbClr val="F1F4FB"/>
+            <a:srgbClr val="1E2761"/>
           </a:solidFill>
           <a:ln>
             <a:noFill/>
@@ -9301,107 +9778,32 @@
           </a:fontRef>
         </p:style>
         <p:txBody>
-          <a:bodyPr rtlCol="0" anchor="ctr"/>
+          <a:bodyPr rtlCol="0" anchor="ctr" wrap="none"/>
           <a:lstStyle/>
           <a:p>
             <a:pPr algn="ctr"/>
-          </a:p>
-        </p:txBody>
-      </p:sp>
-      <p:sp>
-        <p:nvSpPr>
-          <p:cNvPr id="10" name="TextBox 9"/>
+            <a:r>
+              <a:rPr sz="1100" b="1">
+                <a:solidFill>
+                  <a:srgbClr val="FFFFFF"/>
+                </a:solidFill>
+                <a:latin typeface="Cambria"/>
+              </a:rPr>
+              <a:t>●</a:t>
+            </a:r>
+          </a:p>
+        </p:txBody>
+      </p:sp>
+      <p:sp>
+        <p:nvSpPr>
+          <p:cNvPr id="8" name="TextBox 7"/>
           <p:cNvSpPr txBox="1"/>
           <p:nvPr/>
         </p:nvSpPr>
         <p:spPr>
           <a:xfrm>
-            <a:off x="8138159" y="2057400"/>
-            <a:ext cx="3520440" cy="1005840"/>
-          </a:xfrm>
-          <a:prstGeom prst="rect">
-            <a:avLst/>
-          </a:prstGeom>
-          <a:noFill/>
-        </p:spPr>
-        <p:txBody>
-          <a:bodyPr wrap="square" anchor="t">
-            <a:spAutoFit/>
-          </a:bodyPr>
-          <a:lstStyle/>
-          <a:p>
-            <a:pPr algn="ctr">
-              <a:spcBef>
-                <a:spcPts val="0"/>
-              </a:spcBef>
-              <a:spcAft>
-                <a:spcPts val="200"/>
-              </a:spcAft>
-            </a:pPr>
-            <a:r>
-              <a:rPr sz="4600" b="1" i="0">
-                <a:solidFill>
-                  <a:srgbClr val="1E2761"/>
-                </a:solidFill>
-                <a:latin typeface="Cambria"/>
-              </a:rPr>
-              <a:t>✓</a:t>
-            </a:r>
-          </a:p>
-        </p:txBody>
-      </p:sp>
-      <p:sp>
-        <p:nvSpPr>
-          <p:cNvPr id="11" name="TextBox 10"/>
-          <p:cNvSpPr txBox="1"/>
-          <p:nvPr/>
-        </p:nvSpPr>
-        <p:spPr>
-          <a:xfrm>
-            <a:off x="8321039" y="3154680"/>
-            <a:ext cx="3154680" cy="640080"/>
-          </a:xfrm>
-          <a:prstGeom prst="rect">
-            <a:avLst/>
-          </a:prstGeom>
-          <a:noFill/>
-        </p:spPr>
-        <p:txBody>
-          <a:bodyPr wrap="square" anchor="t">
-            <a:spAutoFit/>
-          </a:bodyPr>
-          <a:lstStyle/>
-          <a:p>
-            <a:pPr algn="ctr">
-              <a:spcBef>
-                <a:spcPts val="0"/>
-              </a:spcBef>
-              <a:spcAft>
-                <a:spcPts val="200"/>
-              </a:spcAft>
-            </a:pPr>
-            <a:r>
-              <a:rPr sz="1400" b="0" i="0">
-                <a:solidFill>
-                  <a:srgbClr val="222222"/>
-                </a:solidFill>
-                <a:latin typeface="Calibri"/>
-              </a:rPr>
-              <a:t>escalonado + filtros activos</a:t>
-            </a:r>
-          </a:p>
-        </p:txBody>
-      </p:sp>
-      <p:sp>
-        <p:nvSpPr>
-          <p:cNvPr id="12" name="TextBox 11"/>
-          <p:cNvSpPr txBox="1"/>
-          <p:nvPr/>
-        </p:nvSpPr>
-        <p:spPr>
-          <a:xfrm>
-            <a:off x="640080" y="4297680"/>
-            <a:ext cx="10972800" cy="1463040"/>
+            <a:off x="1463040" y="3694176"/>
+            <a:ext cx="10058400" cy="777240"/>
           </a:xfrm>
           <a:prstGeom prst="rect">
             <a:avLst/>
@@ -9419,36 +9821,17 @@
                 <a:spcPts val="0"/>
               </a:spcBef>
               <a:spcAft>
-                <a:spcPts val="800"/>
+                <a:spcPts val="100"/>
               </a:spcAft>
             </a:pPr>
             <a:r>
-              <a:rPr sz="1600" b="0" i="0">
-                <a:solidFill>
-                  <a:srgbClr val="222222"/>
+              <a:rPr sz="1700" b="1" i="0">
+                <a:solidFill>
+                  <a:srgbClr val="1E2761"/>
                 </a:solidFill>
                 <a:latin typeface="Calibri"/>
               </a:rPr>
-              <a:t>Resultados validados contra los backtests originales (Anexos 20 y 22).</a:t>
-            </a:r>
-          </a:p>
-          <a:p>
-            <a:pPr algn="l">
-              <a:spcBef>
-                <a:spcPts val="0"/>
-              </a:spcBef>
-              <a:spcAft>
-                <a:spcPts val="800"/>
-              </a:spcAft>
-            </a:pPr>
-            <a:r>
-              <a:rPr sz="1600" b="0" i="0">
-                <a:solidFill>
-                  <a:srgbClr val="222222"/>
-                </a:solidFill>
-                <a:latin typeface="Calibri"/>
-              </a:rPr>
-              <a:t>Calibración por estrategia (SL, ventana, ATR, escalado) auditable y reversible.</a:t>
+              <a:t>Salida</a:t>
             </a:r>
           </a:p>
           <a:p>
@@ -9461,13 +9844,283 @@
               </a:spcAft>
             </a:pPr>
             <a:r>
-              <a:rPr sz="1600" b="0" i="0">
+              <a:rPr sz="1400" b="0" i="0">
                 <a:solidFill>
                   <a:srgbClr val="222222"/>
                 </a:solidFill>
                 <a:latin typeface="Calibri"/>
               </a:rPr>
-              <a:t>Una semana de operación en demo en curso para confirmar fills reales.</a:t>
+              <a:t>Smart Trail o Trend Catcher — trailing de tendencia; los dos mejores usan Smart Trail.</a:t>
+            </a:r>
+          </a:p>
+        </p:txBody>
+      </p:sp>
+      <p:sp>
+        <p:nvSpPr>
+          <p:cNvPr id="9" name="Oval 8"/>
+          <p:cNvSpPr/>
+          <p:nvPr/>
+        </p:nvSpPr>
+        <p:spPr>
+          <a:xfrm>
+            <a:off x="731520" y="4562856"/>
+            <a:ext cx="502920" cy="502920"/>
+          </a:xfrm>
+          <a:prstGeom prst="ellipse">
+            <a:avLst/>
+          </a:prstGeom>
+          <a:solidFill>
+            <a:srgbClr val="1E2761"/>
+          </a:solidFill>
+          <a:ln>
+            <a:noFill/>
+          </a:ln>
+          <a:effectLst/>
+        </p:spPr>
+        <p:style>
+          <a:lnRef idx="1">
+            <a:schemeClr val="accent1"/>
+          </a:lnRef>
+          <a:fillRef idx="3">
+            <a:schemeClr val="accent1"/>
+          </a:fillRef>
+          <a:effectRef idx="2">
+            <a:schemeClr val="accent1"/>
+          </a:effectRef>
+          <a:fontRef idx="minor">
+            <a:schemeClr val="lt1"/>
+          </a:fontRef>
+        </p:style>
+        <p:txBody>
+          <a:bodyPr rtlCol="0" anchor="ctr" wrap="none"/>
+          <a:lstStyle/>
+          <a:p>
+            <a:pPr algn="ctr"/>
+            <a:r>
+              <a:rPr sz="1100" b="1">
+                <a:solidFill>
+                  <a:srgbClr val="FFFFFF"/>
+                </a:solidFill>
+                <a:latin typeface="Cambria"/>
+              </a:rPr>
+              <a:t>●</a:t>
+            </a:r>
+          </a:p>
+        </p:txBody>
+      </p:sp>
+      <p:sp>
+        <p:nvSpPr>
+          <p:cNvPr id="10" name="TextBox 9"/>
+          <p:cNvSpPr txBox="1"/>
+          <p:nvPr/>
+        </p:nvSpPr>
+        <p:spPr>
+          <a:xfrm>
+            <a:off x="1463040" y="4535424"/>
+            <a:ext cx="10058400" cy="777240"/>
+          </a:xfrm>
+          <a:prstGeom prst="rect">
+            <a:avLst/>
+          </a:prstGeom>
+          <a:noFill/>
+        </p:spPr>
+        <p:txBody>
+          <a:bodyPr wrap="square" anchor="t">
+            <a:spAutoFit/>
+          </a:bodyPr>
+          <a:lstStyle/>
+          <a:p>
+            <a:pPr algn="l">
+              <a:spcBef>
+                <a:spcPts val="0"/>
+              </a:spcBef>
+              <a:spcAft>
+                <a:spcPts val="100"/>
+              </a:spcAft>
+            </a:pPr>
+            <a:r>
+              <a:rPr sz="1700" b="1" i="0">
+                <a:solidFill>
+                  <a:srgbClr val="1E2761"/>
+                </a:solidFill>
+                <a:latin typeface="Calibri"/>
+              </a:rPr>
+              <a:t>Mercado</a:t>
+            </a:r>
+          </a:p>
+          <a:p>
+            <a:pPr algn="l">
+              <a:spcBef>
+                <a:spcPts val="0"/>
+              </a:spcBef>
+              <a:spcAft>
+                <a:spcPts val="200"/>
+              </a:spcAft>
+            </a:pPr>
+            <a:r>
+              <a:rPr sz="1400" b="0" i="0">
+                <a:solidFill>
+                  <a:srgbClr val="222222"/>
+                </a:solidFill>
+                <a:latin typeface="Calibri"/>
+              </a:rPr>
+              <a:t>Índices y oro = sweet spot. Evitar contrarian puro de FX con osciladores extremos.</a:t>
+            </a:r>
+          </a:p>
+        </p:txBody>
+      </p:sp>
+      <p:sp>
+        <p:nvSpPr>
+          <p:cNvPr id="11" name="Oval 10"/>
+          <p:cNvSpPr/>
+          <p:nvPr/>
+        </p:nvSpPr>
+        <p:spPr>
+          <a:xfrm>
+            <a:off x="731520" y="5404104"/>
+            <a:ext cx="502920" cy="502920"/>
+          </a:xfrm>
+          <a:prstGeom prst="ellipse">
+            <a:avLst/>
+          </a:prstGeom>
+          <a:solidFill>
+            <a:srgbClr val="1E2761"/>
+          </a:solidFill>
+          <a:ln>
+            <a:noFill/>
+          </a:ln>
+          <a:effectLst/>
+        </p:spPr>
+        <p:style>
+          <a:lnRef idx="1">
+            <a:schemeClr val="accent1"/>
+          </a:lnRef>
+          <a:fillRef idx="3">
+            <a:schemeClr val="accent1"/>
+          </a:fillRef>
+          <a:effectRef idx="2">
+            <a:schemeClr val="accent1"/>
+          </a:effectRef>
+          <a:fontRef idx="minor">
+            <a:schemeClr val="lt1"/>
+          </a:fontRef>
+        </p:style>
+        <p:txBody>
+          <a:bodyPr rtlCol="0" anchor="ctr" wrap="none"/>
+          <a:lstStyle/>
+          <a:p>
+            <a:pPr algn="ctr"/>
+            <a:r>
+              <a:rPr sz="1100" b="1">
+                <a:solidFill>
+                  <a:srgbClr val="FFFFFF"/>
+                </a:solidFill>
+                <a:latin typeface="Cambria"/>
+              </a:rPr>
+              <a:t>●</a:t>
+            </a:r>
+          </a:p>
+        </p:txBody>
+      </p:sp>
+      <p:sp>
+        <p:nvSpPr>
+          <p:cNvPr id="12" name="TextBox 11"/>
+          <p:cNvSpPr txBox="1"/>
+          <p:nvPr/>
+        </p:nvSpPr>
+        <p:spPr>
+          <a:xfrm>
+            <a:off x="1463040" y="5376672"/>
+            <a:ext cx="10058400" cy="777240"/>
+          </a:xfrm>
+          <a:prstGeom prst="rect">
+            <a:avLst/>
+          </a:prstGeom>
+          <a:noFill/>
+        </p:spPr>
+        <p:txBody>
+          <a:bodyPr wrap="square" anchor="t">
+            <a:spAutoFit/>
+          </a:bodyPr>
+          <a:lstStyle/>
+          <a:p>
+            <a:pPr algn="l">
+              <a:spcBef>
+                <a:spcPts val="0"/>
+              </a:spcBef>
+              <a:spcAft>
+                <a:spcPts val="100"/>
+              </a:spcAft>
+            </a:pPr>
+            <a:r>
+              <a:rPr sz="1700" b="1" i="0">
+                <a:solidFill>
+                  <a:srgbClr val="1E2761"/>
+                </a:solidFill>
+                <a:latin typeface="Calibri"/>
+              </a:rPr>
+              <a:t>Timeframe</a:t>
+            </a:r>
+          </a:p>
+          <a:p>
+            <a:pPr algn="l">
+              <a:spcBef>
+                <a:spcPts val="0"/>
+              </a:spcBef>
+              <a:spcAft>
+                <a:spcPts val="200"/>
+              </a:spcAft>
+            </a:pPr>
+            <a:r>
+              <a:rPr sz="1400" b="0" i="0">
+                <a:solidFill>
+                  <a:srgbClr val="222222"/>
+                </a:solidFill>
+                <a:latin typeface="Calibri"/>
+              </a:rPr>
+              <a:t>5m rindió mejor que 15m en este conjunto.</a:t>
+            </a:r>
+          </a:p>
+        </p:txBody>
+      </p:sp>
+      <p:sp>
+        <p:nvSpPr>
+          <p:cNvPr id="13" name="TextBox 12"/>
+          <p:cNvSpPr txBox="1"/>
+          <p:nvPr/>
+        </p:nvSpPr>
+        <p:spPr>
+          <a:xfrm>
+            <a:off x="731520" y="6355080"/>
+            <a:ext cx="10972800" cy="365760"/>
+          </a:xfrm>
+          <a:prstGeom prst="rect">
+            <a:avLst/>
+          </a:prstGeom>
+          <a:noFill/>
+        </p:spPr>
+        <p:txBody>
+          <a:bodyPr wrap="square" anchor="t">
+            <a:spAutoFit/>
+          </a:bodyPr>
+          <a:lstStyle/>
+          <a:p>
+            <a:pPr algn="l">
+              <a:spcBef>
+                <a:spcPts val="0"/>
+              </a:spcBef>
+              <a:spcAft>
+                <a:spcPts val="200"/>
+              </a:spcAft>
+            </a:pPr>
+            <a:r>
+              <a:rPr sz="1100" b="0" i="1">
+                <a:solidFill>
+                  <a:srgbClr val="6B7280"/>
+                </a:solidFill>
+                <a:latin typeface="Calibri"/>
+              </a:rPr>
+              <a:t>Tendencias sobre 8 estrategias (muestra pequeña) — a confirmar con más datos en demo.</a:t>
             </a:r>
           </a:p>
         </p:txBody>

</xml_diff>